<commit_message>
Use credential-free Claude marketplace install
</commit_message>
<xml_diff>
--- a/docs/alignhcm-brand-system/dist/Align-HCM-Claude-Skill-Quick-Start.pptx
+++ b/docs/alignhcm-brand-system/dist/Align-HCM-Claude-Skill-Quick-Start.pptx
@@ -3636,7 +3636,7 @@
           <p:cNvPr id="16" name="OrganizationGuideLabel">
             <a:extLst>
               <a:ext uri="{FF2B5EF4-FFF2-40B4-BE49-F238E27FC236}">
-                <a16:creationId xmlns:a16="http://schemas.microsoft.com/office/drawing/2014/main" id="{7A631DAE-BFFE-EBBB-C90B-D34616654784}"/>
+                <a16:creationId xmlns:a16="http://schemas.microsoft.com/office/drawing/2014/main" id="{99DEB18A-7F67-B802-EBE7-51122964DD7D}"/>
               </a:ext>
             </a:extLst>
           </p:cNvPr>
@@ -5312,7 +5312,23 @@
                 </a:solidFill>
                 <a:latin typeface="Consolas" panose="020B0609020204030204" pitchFamily="49" charset="0"/>
               </a:rPr>
-              <a:t>dillonmohr8777/claude-skills-repo</a:t>
+              <a:t>https://github.com/dillonmohr8777/</a:t>
+            </a:r>
+          </a:p>
+          <a:p>
+            <a:pPr algn="l">
+              <a:lnSpc>
+                <a:spcPct val="122000"/>
+              </a:lnSpc>
+            </a:pPr>
+            <a:r>
+              <a:rPr lang="en-US" sz="1250" b="0" i="0">
+                <a:solidFill>
+                  <a:srgbClr val="EDF2F8"/>
+                </a:solidFill>
+                <a:latin typeface="Consolas" panose="020B0609020204030204" pitchFamily="49" charset="0"/>
+              </a:rPr>
+              <a:t>claude-skills-repo.git</a:t>
             </a:r>
             <a:endParaRPr sz="1250" b="0" i="0">
               <a:solidFill>
@@ -6077,7 +6093,7 @@
     </p:spTree>
     <p:extLst>
       <p:ext uri="{BB962C8B-B14F-4D97-AF65-F5344CB8AC3E}">
-        <p14:creationId xmlns:p14="http://schemas.microsoft.com/office/powerpoint/2010/main" val="293021806"/>
+        <p14:creationId xmlns:p14="http://schemas.microsoft.com/office/powerpoint/2010/main" val="4225153829"/>
       </p:ext>
     </p:extLst>
   </p:cSld>
@@ -8216,7 +8232,7 @@
     </p:spTree>
     <p:extLst>
       <p:ext uri="{BB962C8B-B14F-4D97-AF65-F5344CB8AC3E}">
-        <p14:creationId xmlns:p14="http://schemas.microsoft.com/office/powerpoint/2010/main" val="2999632143"/>
+        <p14:creationId xmlns:p14="http://schemas.microsoft.com/office/powerpoint/2010/main" val="805756774"/>
       </p:ext>
     </p:extLst>
   </p:cSld>

</xml_diff>

<commit_message>
Enable Align skill for team rollout
</commit_message>
<xml_diff>
--- a/docs/alignhcm-brand-system/dist/Align-HCM-Claude-Skill-Quick-Start.pptx
+++ b/docs/alignhcm-brand-system/dist/Align-HCM-Claude-Skill-Quick-Start.pptx
@@ -3636,7 +3636,7 @@
           <p:cNvPr id="16" name="OrganizationGuideLabel">
             <a:extLst>
               <a:ext uri="{FF2B5EF4-FFF2-40B4-BE49-F238E27FC236}">
-                <a16:creationId xmlns:a16="http://schemas.microsoft.com/office/drawing/2014/main" id="{99DEB18A-7F67-B802-EBE7-51122964DD7D}"/>
+                <a16:creationId xmlns:a16="http://schemas.microsoft.com/office/drawing/2014/main" id="{DB2B318D-D104-11A9-005F-535A29B71911}"/>
               </a:ext>
             </a:extLst>
           </p:cNvPr>
@@ -5084,15 +5084,15 @@
           <a:p>
             <a:pPr algn="l"/>
             <a:r>
-              <a:rPr lang="en-US" sz="1700" b="0" i="0">
+              <a:rPr lang="en-US" sz="1600" b="0" i="0">
                 <a:solidFill>
                   <a:srgbClr val="2B3849"/>
                 </a:solidFill>
                 <a:latin typeface="Calibri"/>
               </a:rPr>
-              <a:t>PR #22 must be merged before the organization uses the main-branch commands below.</a:t>
-            </a:r>
-            <a:endParaRPr sz="1700" b="0" i="0">
+              <a:t>The marketplace is live. Use managed settings for organization rollout or the commands below as a manual fallback.</a:t>
+            </a:r>
+            <a:endParaRPr sz="1600" b="0" i="0">
               <a:solidFill>
                 <a:srgbClr val="2B3849"/>
               </a:solidFill>
@@ -6093,7 +6093,7 @@
     </p:spTree>
     <p:extLst>
       <p:ext uri="{BB962C8B-B14F-4D97-AF65-F5344CB8AC3E}">
-        <p14:creationId xmlns:p14="http://schemas.microsoft.com/office/powerpoint/2010/main" val="4225153829"/>
+        <p14:creationId xmlns:p14="http://schemas.microsoft.com/office/powerpoint/2010/main" val="4102516609"/>
       </p:ext>
     </p:extLst>
   </p:cSld>
@@ -8232,7 +8232,7 @@
     </p:spTree>
     <p:extLst>
       <p:ext uri="{BB962C8B-B14F-4D97-AF65-F5344CB8AC3E}">
-        <p14:creationId xmlns:p14="http://schemas.microsoft.com/office/powerpoint/2010/main" val="805756774"/>
+        <p14:creationId xmlns:p14="http://schemas.microsoft.com/office/powerpoint/2010/main" val="2691342258"/>
       </p:ext>
     </p:extLst>
   </p:cSld>

</xml_diff>